<commit_message>
Created draw.io architecture diagram
</commit_message>
<xml_diff>
--- a/SMArT_Complete_Presentation With Gantt Chart.pptx
+++ b/SMArT_Complete_Presentation With Gantt Chart.pptx
@@ -134,6 +134,67 @@
     </p:ext>
   </p:extLst>
 </p:presentation>
+</file>
+
+<file path=ppt/revisionInfo.xml><?xml version="1.0" encoding="utf-8"?>
+<p1510:revInfo xmlns:a="http://schemas.openxmlformats.org/drawingml/2006/main" xmlns:r="http://schemas.openxmlformats.org/officeDocument/2006/relationships" xmlns:p1510="http://schemas.microsoft.com/office/powerpoint/2015/10/main">
+  <p1510:revLst>
+    <p1510:client id="{DDF4BDDD-5F54-4A57-BB3D-350F8522ECE0}" v="1" dt="2026-06-10T07:12:24.406"/>
+  </p1510:revLst>
+</p1510:revInfo>
+</file>
+
+<file path=ppt/changesInfos/changesInfo1.xml><?xml version="1.0" encoding="utf-8"?>
+<pc:chgInfo xmlns:a="http://schemas.openxmlformats.org/drawingml/2006/main" xmlns:r="http://schemas.openxmlformats.org/officeDocument/2006/relationships" xmlns:ac="http://schemas.microsoft.com/office/drawing/2013/main/command" xmlns:pc="http://schemas.microsoft.com/office/powerpoint/2013/main/command">
+  <pc:docChgLst>
+    <pc:chgData name="Pramod Naik" userId="ceb6df04-ef15-4d9b-a141-998a03559d75" providerId="ADAL" clId="{62E9B5AE-779D-4001-92D3-8FF830A8A9C1}"/>
+    <pc:docChg chg="modSld">
+      <pc:chgData name="Pramod Naik" userId="ceb6df04-ef15-4d9b-a141-998a03559d75" providerId="ADAL" clId="{62E9B5AE-779D-4001-92D3-8FF830A8A9C1}" dt="2026-06-10T07:12:32.488" v="64" actId="20577"/>
+      <pc:docMkLst>
+        <pc:docMk/>
+      </pc:docMkLst>
+      <pc:sldChg chg="addSp modSp mod">
+        <pc:chgData name="Pramod Naik" userId="ceb6df04-ef15-4d9b-a141-998a03559d75" providerId="ADAL" clId="{62E9B5AE-779D-4001-92D3-8FF830A8A9C1}" dt="2026-06-10T07:12:32.488" v="64" actId="20577"/>
+        <pc:sldMkLst>
+          <pc:docMk/>
+          <pc:sldMk cId="0" sldId="279"/>
+        </pc:sldMkLst>
+        <pc:spChg chg="mod">
+          <ac:chgData name="Pramod Naik" userId="ceb6df04-ef15-4d9b-a141-998a03559d75" providerId="ADAL" clId="{62E9B5AE-779D-4001-92D3-8FF830A8A9C1}" dt="2026-06-10T07:11:56.281" v="60" actId="1038"/>
+          <ac:spMkLst>
+            <pc:docMk/>
+            <pc:sldMk cId="0" sldId="279"/>
+            <ac:spMk id="178" creationId="{00000000-0000-0000-0000-000000000000}"/>
+          </ac:spMkLst>
+        </pc:spChg>
+        <pc:spChg chg="mod">
+          <ac:chgData name="Pramod Naik" userId="ceb6df04-ef15-4d9b-a141-998a03559d75" providerId="ADAL" clId="{62E9B5AE-779D-4001-92D3-8FF830A8A9C1}" dt="2026-06-10T07:11:56.281" v="60" actId="1038"/>
+          <ac:spMkLst>
+            <pc:docMk/>
+            <pc:sldMk cId="0" sldId="279"/>
+            <ac:spMk id="179" creationId="{00000000-0000-0000-0000-000000000000}"/>
+          </ac:spMkLst>
+        </pc:spChg>
+        <pc:spChg chg="mod">
+          <ac:chgData name="Pramod Naik" userId="ceb6df04-ef15-4d9b-a141-998a03559d75" providerId="ADAL" clId="{62E9B5AE-779D-4001-92D3-8FF830A8A9C1}" dt="2026-06-10T07:11:56.281" v="60" actId="1038"/>
+          <ac:spMkLst>
+            <pc:docMk/>
+            <pc:sldMk cId="0" sldId="279"/>
+            <ac:spMk id="180" creationId="{00000000-0000-0000-0000-000000000000}"/>
+          </ac:spMkLst>
+        </pc:spChg>
+        <pc:spChg chg="add mod">
+          <ac:chgData name="Pramod Naik" userId="ceb6df04-ef15-4d9b-a141-998a03559d75" providerId="ADAL" clId="{62E9B5AE-779D-4001-92D3-8FF830A8A9C1}" dt="2026-06-10T07:12:32.488" v="64" actId="20577"/>
+          <ac:spMkLst>
+            <pc:docMk/>
+            <pc:sldMk cId="0" sldId="279"/>
+            <ac:spMk id="190" creationId="{265D1CD6-35E7-A9CE-4090-6B7EB46ED159}"/>
+          </ac:spMkLst>
+        </pc:spChg>
+      </pc:sldChg>
+    </pc:docChg>
+  </pc:docChgLst>
+</pc:chgInfo>
 </file>
 
 <file path=ppt/charts/chart1.xml><?xml version="1.0" encoding="utf-8"?>
@@ -36219,7 +36280,7 @@
         </p:nvSpPr>
         <p:spPr>
           <a:xfrm>
-            <a:off x="7434610" y="4370832"/>
+            <a:off x="7282210" y="4370832"/>
             <a:ext cx="808975" cy="274320"/>
           </a:xfrm>
           <a:prstGeom prst="rect">
@@ -36253,7 +36314,7 @@
         </p:nvSpPr>
         <p:spPr>
           <a:xfrm>
-            <a:off x="7896113" y="4370832"/>
+            <a:off x="7743713" y="4370832"/>
             <a:ext cx="329184" cy="274320"/>
           </a:xfrm>
           <a:prstGeom prst="rect">
@@ -36289,7 +36350,7 @@
         </p:nvSpPr>
         <p:spPr>
           <a:xfrm rot="2700000">
-            <a:off x="8170433" y="4434840"/>
+            <a:off x="8018033" y="4434840"/>
             <a:ext cx="118872" cy="118872"/>
           </a:xfrm>
           <a:prstGeom prst="rect">
@@ -36560,6 +36621,56 @@
               <a:t>Start: 15 Jun 2026  ·  3 Resources (Tech Lead, Backend Dev, Data Eng)  ·  Completion: 28 Sept 2026  ·  ⚡ Phases 3 &amp; 4 parallel — saves ~3 weeks</a:t>
             </a:r>
             <a:endParaRPr lang="en-US" sz="850" dirty="0"/>
+          </a:p>
+        </p:txBody>
+      </p:sp>
+      <p:sp>
+        <p:nvSpPr>
+          <p:cNvPr id="190" name="Text 160">
+            <a:extLst>
+              <a:ext uri="{FF2B5EF4-FFF2-40B4-BE49-F238E27FC236}">
+                <a16:creationId xmlns:a16="http://schemas.microsoft.com/office/drawing/2014/main" id="{265D1CD6-35E7-A9CE-4090-6B7EB46ED159}"/>
+              </a:ext>
+            </a:extLst>
+          </p:cNvPr>
+          <p:cNvSpPr/>
+          <p:nvPr/>
+        </p:nvSpPr>
+        <p:spPr>
+          <a:xfrm>
+            <a:off x="5854311" y="3026664"/>
+            <a:ext cx="329184" cy="274320"/>
+          </a:xfrm>
+          <a:prstGeom prst="rect">
+            <a:avLst/>
+          </a:prstGeom>
+          <a:noFill/>
+          <a:ln/>
+        </p:spPr>
+        <p:txBody>
+          <a:bodyPr wrap="square" rtlCol="0" anchor="ctr"/>
+          <a:lstStyle/>
+          <a:p>
+            <a:pPr marL="0" indent="0" algn="ctr">
+              <a:buNone/>
+            </a:pPr>
+            <a:r>
+              <a:rPr lang="en-US" sz="800" b="1" dirty="0">
+                <a:solidFill>
+                  <a:srgbClr val="FFFFFF"/>
+                </a:solidFill>
+              </a:rPr>
+              <a:t>1</a:t>
+            </a:r>
+            <a:r>
+              <a:rPr lang="en-US" sz="800" b="1">
+                <a:solidFill>
+                  <a:srgbClr val="FFFFFF"/>
+                </a:solidFill>
+              </a:rPr>
+              <a:t>w</a:t>
+            </a:r>
+            <a:endParaRPr lang="en-US" sz="800" dirty="0"/>
           </a:p>
         </p:txBody>
       </p:sp>

</xml_diff>